<commit_message>
Edited diagrams to make it more in line with the milestones
</commit_message>
<xml_diff>
--- a/docs/Milestone 2(3) System Design/MIS3371-Three-Tier-Architecture.pptx
+++ b/docs/Milestone 2(3) System Design/MIS3371-Three-Tier-Architecture.pptx
@@ -112,14 +112,6 @@
 </p:presentation>
 </file>
 
-<file path=ppt/revisionInfo.xml><?xml version="1.0" encoding="utf-8"?>
-<p1510:revInfo xmlns:a="http://schemas.openxmlformats.org/drawingml/2006/main" xmlns:r="http://schemas.openxmlformats.org/officeDocument/2006/relationships" xmlns:p1510="http://schemas.microsoft.com/office/powerpoint/2015/10/main">
-  <p1510:revLst>
-    <p1510:client id="{FE67341E-E479-4650-9089-8B05C08464D9}" v="1" dt="2026-09-21T03:53:23.672"/>
-  </p1510:revLst>
-</p1510:revInfo>
-</file>
-
 <file path=ppt/changesInfos/changesInfo1.xml><?xml version="1.0" encoding="utf-8"?>
 <pc:chgInfo xmlns:a="http://schemas.openxmlformats.org/drawingml/2006/main" xmlns:r="http://schemas.openxmlformats.org/officeDocument/2006/relationships" xmlns:ac="http://schemas.microsoft.com/office/drawing/2013/main/command" xmlns:pc="http://schemas.microsoft.com/office/powerpoint/2013/main/command">
   <pc:docChgLst>
@@ -135,12 +127,68 @@
           <pc:docMk/>
           <pc:sldMk cId="2756200121" sldId="256"/>
         </pc:sldMkLst>
-        <pc:spChg chg="add del mod">
-          <ac:chgData name="Andrea Esparza" userId="43595e91f8375488" providerId="LiveId" clId="{00ADF1BE-D2B6-4329-AA31-D335C45925FB}" dt="2026-09-21T03:53:24.404" v="2"/>
+      </pc:sldChg>
+    </pc:docChg>
+  </pc:docChgLst>
+  <pc:docChgLst>
+    <pc:chgData name="Satya Dwiputranto" userId="ef02b4c7f33198b7" providerId="LiveId" clId="{9E7903C8-EB04-40E0-9AFD-0CEB9D80B36F}"/>
+    <pc:docChg chg="custSel modSld">
+      <pc:chgData name="Satya Dwiputranto" userId="ef02b4c7f33198b7" providerId="LiveId" clId="{9E7903C8-EB04-40E0-9AFD-0CEB9D80B36F}" dt="2026-10-21T01:57:31.193" v="93" actId="20577"/>
+      <pc:docMkLst>
+        <pc:docMk/>
+      </pc:docMkLst>
+      <pc:sldChg chg="addSp modSp mod">
+        <pc:chgData name="Satya Dwiputranto" userId="ef02b4c7f33198b7" providerId="LiveId" clId="{9E7903C8-EB04-40E0-9AFD-0CEB9D80B36F}" dt="2026-10-21T01:57:31.193" v="93" actId="20577"/>
+        <pc:sldMkLst>
+          <pc:docMk/>
+          <pc:sldMk cId="2756200121" sldId="256"/>
+        </pc:sldMkLst>
+        <pc:spChg chg="add mod">
+          <ac:chgData name="Satya Dwiputranto" userId="ef02b4c7f33198b7" providerId="LiveId" clId="{9E7903C8-EB04-40E0-9AFD-0CEB9D80B36F}" dt="2026-10-21T01:57:24.733" v="74" actId="20577"/>
           <ac:spMkLst>
             <pc:docMk/>
             <pc:sldMk cId="2756200121" sldId="256"/>
-            <ac:spMk id="3" creationId="{00BF057B-4544-80BA-7F24-5C9748C8BE43}"/>
+            <ac:spMk id="4" creationId="{22959F94-7D0F-C1D9-08CC-EFC8A07AAF69}"/>
+          </ac:spMkLst>
+        </pc:spChg>
+        <pc:spChg chg="mod">
+          <ac:chgData name="Satya Dwiputranto" userId="ef02b4c7f33198b7" providerId="LiveId" clId="{9E7903C8-EB04-40E0-9AFD-0CEB9D80B36F}" dt="2026-10-21T01:56:11.858" v="11" actId="20577"/>
+          <ac:spMkLst>
+            <pc:docMk/>
+            <pc:sldMk cId="2756200121" sldId="256"/>
+            <ac:spMk id="22" creationId="{D07744C1-3452-6A67-409C-1ABB449E1861}"/>
+          </ac:spMkLst>
+        </pc:spChg>
+        <pc:spChg chg="mod">
+          <ac:chgData name="Satya Dwiputranto" userId="ef02b4c7f33198b7" providerId="LiveId" clId="{9E7903C8-EB04-40E0-9AFD-0CEB9D80B36F}" dt="2026-10-21T01:56:31.031" v="27" actId="122"/>
+          <ac:spMkLst>
+            <pc:docMk/>
+            <pc:sldMk cId="2756200121" sldId="256"/>
+            <ac:spMk id="24" creationId="{C5565A45-8628-960E-677E-1E4AE2A40867}"/>
+          </ac:spMkLst>
+        </pc:spChg>
+        <pc:spChg chg="mod">
+          <ac:chgData name="Satya Dwiputranto" userId="ef02b4c7f33198b7" providerId="LiveId" clId="{9E7903C8-EB04-40E0-9AFD-0CEB9D80B36F}" dt="2026-10-21T01:56:38.213" v="39" actId="20577"/>
+          <ac:spMkLst>
+            <pc:docMk/>
+            <pc:sldMk cId="2756200121" sldId="256"/>
+            <ac:spMk id="36" creationId="{933A3837-9669-7211-A5F3-222A2EA084D0}"/>
+          </ac:spMkLst>
+        </pc:spChg>
+        <pc:spChg chg="mod">
+          <ac:chgData name="Satya Dwiputranto" userId="ef02b4c7f33198b7" providerId="LiveId" clId="{9E7903C8-EB04-40E0-9AFD-0CEB9D80B36F}" dt="2026-10-21T01:56:49.600" v="54" actId="20577"/>
+          <ac:spMkLst>
+            <pc:docMk/>
+            <pc:sldMk cId="2756200121" sldId="256"/>
+            <ac:spMk id="38" creationId="{881D4A7A-DCA1-4412-3F64-E9B20317B6F9}"/>
+          </ac:spMkLst>
+        </pc:spChg>
+        <pc:spChg chg="mod">
+          <ac:chgData name="Satya Dwiputranto" userId="ef02b4c7f33198b7" providerId="LiveId" clId="{9E7903C8-EB04-40E0-9AFD-0CEB9D80B36F}" dt="2026-10-21T01:57:31.193" v="93" actId="20577"/>
+          <ac:spMkLst>
+            <pc:docMk/>
+            <pc:sldMk cId="2756200121" sldId="256"/>
+            <ac:spMk id="40" creationId="{165DEF07-E2D1-6ED8-0D73-2E7F5736BE37}"/>
           </ac:spMkLst>
         </pc:spChg>
       </pc:sldChg>
@@ -280,7 +328,7 @@
           <a:p>
             <a:fld id="{9B6C9762-007E-4E37-8924-9C354059CE6E}" type="datetimeFigureOut">
               <a:rPr lang="en-US" smtClean="0"/>
-              <a:t>9/20/2026</a:t>
+              <a:t>10/20/2026</a:t>
             </a:fld>
             <a:endParaRPr lang="en-US"/>
           </a:p>
@@ -450,7 +498,7 @@
           <a:p>
             <a:fld id="{9B6C9762-007E-4E37-8924-9C354059CE6E}" type="datetimeFigureOut">
               <a:rPr lang="en-US" smtClean="0"/>
-              <a:t>9/20/2026</a:t>
+              <a:t>10/20/2026</a:t>
             </a:fld>
             <a:endParaRPr lang="en-US"/>
           </a:p>
@@ -630,7 +678,7 @@
           <a:p>
             <a:fld id="{9B6C9762-007E-4E37-8924-9C354059CE6E}" type="datetimeFigureOut">
               <a:rPr lang="en-US" smtClean="0"/>
-              <a:t>9/20/2026</a:t>
+              <a:t>10/20/2026</a:t>
             </a:fld>
             <a:endParaRPr lang="en-US"/>
           </a:p>
@@ -800,7 +848,7 @@
           <a:p>
             <a:fld id="{9B6C9762-007E-4E37-8924-9C354059CE6E}" type="datetimeFigureOut">
               <a:rPr lang="en-US" smtClean="0"/>
-              <a:t>9/20/2026</a:t>
+              <a:t>10/20/2026</a:t>
             </a:fld>
             <a:endParaRPr lang="en-US"/>
           </a:p>
@@ -1046,7 +1094,7 @@
           <a:p>
             <a:fld id="{9B6C9762-007E-4E37-8924-9C354059CE6E}" type="datetimeFigureOut">
               <a:rPr lang="en-US" smtClean="0"/>
-              <a:t>9/20/2026</a:t>
+              <a:t>10/20/2026</a:t>
             </a:fld>
             <a:endParaRPr lang="en-US"/>
           </a:p>
@@ -1278,7 +1326,7 @@
           <a:p>
             <a:fld id="{9B6C9762-007E-4E37-8924-9C354059CE6E}" type="datetimeFigureOut">
               <a:rPr lang="en-US" smtClean="0"/>
-              <a:t>9/20/2026</a:t>
+              <a:t>10/20/2026</a:t>
             </a:fld>
             <a:endParaRPr lang="en-US"/>
           </a:p>
@@ -1645,7 +1693,7 @@
           <a:p>
             <a:fld id="{9B6C9762-007E-4E37-8924-9C354059CE6E}" type="datetimeFigureOut">
               <a:rPr lang="en-US" smtClean="0"/>
-              <a:t>9/20/2026</a:t>
+              <a:t>10/20/2026</a:t>
             </a:fld>
             <a:endParaRPr lang="en-US"/>
           </a:p>
@@ -1763,7 +1811,7 @@
           <a:p>
             <a:fld id="{9B6C9762-007E-4E37-8924-9C354059CE6E}" type="datetimeFigureOut">
               <a:rPr lang="en-US" smtClean="0"/>
-              <a:t>9/20/2026</a:t>
+              <a:t>10/20/2026</a:t>
             </a:fld>
             <a:endParaRPr lang="en-US"/>
           </a:p>
@@ -1858,7 +1906,7 @@
           <a:p>
             <a:fld id="{9B6C9762-007E-4E37-8924-9C354059CE6E}" type="datetimeFigureOut">
               <a:rPr lang="en-US" smtClean="0"/>
-              <a:t>9/20/2026</a:t>
+              <a:t>10/20/2026</a:t>
             </a:fld>
             <a:endParaRPr lang="en-US"/>
           </a:p>
@@ -2135,7 +2183,7 @@
           <a:p>
             <a:fld id="{9B6C9762-007E-4E37-8924-9C354059CE6E}" type="datetimeFigureOut">
               <a:rPr lang="en-US" smtClean="0"/>
-              <a:t>9/20/2026</a:t>
+              <a:t>10/20/2026</a:t>
             </a:fld>
             <a:endParaRPr lang="en-US"/>
           </a:p>
@@ -2392,7 +2440,7 @@
           <a:p>
             <a:fld id="{9B6C9762-007E-4E37-8924-9C354059CE6E}" type="datetimeFigureOut">
               <a:rPr lang="en-US" smtClean="0"/>
-              <a:t>9/20/2026</a:t>
+              <a:t>10/20/2026</a:t>
             </a:fld>
             <a:endParaRPr lang="en-US"/>
           </a:p>
@@ -2605,7 +2653,7 @@
           <a:p>
             <a:fld id="{9B6C9762-007E-4E37-8924-9C354059CE6E}" type="datetimeFigureOut">
               <a:rPr lang="en-US" smtClean="0"/>
-              <a:t>9/20/2026</a:t>
+              <a:t>10/20/2026</a:t>
             </a:fld>
             <a:endParaRPr lang="en-US"/>
           </a:p>
@@ -3254,14 +3302,7 @@
             <a:pPr algn="ctr"/>
             <a:r>
               <a:rPr lang="en-US" sz="1400" dirty="0"/>
-              <a:t>Mobile App</a:t>
-            </a:r>
-          </a:p>
-          <a:p>
-            <a:pPr algn="ctr"/>
-            <a:r>
-              <a:rPr lang="en-US" sz="1400" dirty="0"/>
-              <a:t>(track rewards)</a:t>
+              <a:t>HTML/CSS</a:t>
             </a:r>
           </a:p>
         </p:txBody>
@@ -3307,15 +3348,10 @@
           <a:bodyPr rtlCol="0" anchor="ctr"/>
           <a:lstStyle/>
           <a:p>
+            <a:pPr algn="ctr"/>
             <a:r>
               <a:rPr lang="en-US" sz="1400" dirty="0"/>
-              <a:t>Point of Sale system in Store</a:t>
-            </a:r>
-          </a:p>
-          <a:p>
-            <a:r>
-              <a:rPr lang="en-US" sz="1400" dirty="0"/>
-              <a:t>(QR code)</a:t>
+              <a:t>App.js</a:t>
             </a:r>
           </a:p>
         </p:txBody>
@@ -3549,7 +3585,7 @@
             <a:pPr algn="ctr"/>
             <a:r>
               <a:rPr lang="en-US" sz="1400" dirty="0"/>
-              <a:t>Web Server/ API </a:t>
+              <a:t>Validation</a:t>
             </a:r>
           </a:p>
         </p:txBody>
@@ -3598,7 +3634,7 @@
             <a:pPr algn="ctr"/>
             <a:r>
               <a:rPr lang="en-US" sz="1400" dirty="0"/>
-              <a:t>Business Rules </a:t>
+              <a:t>Backend.js</a:t>
             </a:r>
           </a:p>
         </p:txBody>
@@ -3617,7 +3653,7 @@
         </p:nvSpPr>
         <p:spPr>
           <a:xfrm>
-            <a:off x="2708695" y="5007810"/>
+            <a:off x="3956738" y="4995856"/>
             <a:ext cx="1440608" cy="603878"/>
           </a:xfrm>
           <a:prstGeom prst="roundRect">
@@ -3646,9 +3682,10 @@
           <a:p>
             <a:pPr algn="ctr"/>
             <a:r>
-              <a:rPr lang="en-US" sz="1400" dirty="0"/>
-              <a:t>DATABASE </a:t>
-            </a:r>
+              <a:rPr lang="en-US" sz="1400"/>
+              <a:t>Transaction Records</a:t>
+            </a:r>
+            <a:endParaRPr lang="en-US" sz="1400" dirty="0"/>
           </a:p>
         </p:txBody>
       </p:sp>
@@ -3875,6 +3912,55 @@
               <a:t>Stores all system information </a:t>
             </a:r>
             <a:endParaRPr lang="en-US" dirty="0"/>
+          </a:p>
+        </p:txBody>
+      </p:sp>
+      <p:sp>
+        <p:nvSpPr>
+          <p:cNvPr id="4" name="Rectangle: Rounded Corners 3">
+            <a:extLst>
+              <a:ext uri="{FF2B5EF4-FFF2-40B4-BE49-F238E27FC236}">
+                <a16:creationId xmlns:a16="http://schemas.microsoft.com/office/drawing/2014/main" id="{22959F94-7D0F-C1D9-08CC-EFC8A07AAF69}"/>
+              </a:ext>
+            </a:extLst>
+          </p:cNvPr>
+          <p:cNvSpPr/>
+          <p:nvPr/>
+        </p:nvSpPr>
+        <p:spPr>
+          <a:xfrm>
+            <a:off x="1334572" y="4976543"/>
+            <a:ext cx="1440608" cy="603878"/>
+          </a:xfrm>
+          <a:prstGeom prst="roundRect">
+            <a:avLst/>
+          </a:prstGeom>
+        </p:spPr>
+        <p:style>
+          <a:lnRef idx="2">
+            <a:schemeClr val="accent1">
+              <a:shade val="15000"/>
+            </a:schemeClr>
+          </a:lnRef>
+          <a:fillRef idx="1">
+            <a:schemeClr val="accent1"/>
+          </a:fillRef>
+          <a:effectRef idx="0">
+            <a:schemeClr val="accent1"/>
+          </a:effectRef>
+          <a:fontRef idx="minor">
+            <a:schemeClr val="lt1"/>
+          </a:fontRef>
+        </p:style>
+        <p:txBody>
+          <a:bodyPr rtlCol="0" anchor="ctr"/>
+          <a:lstStyle/>
+          <a:p>
+            <a:pPr algn="ctr"/>
+            <a:r>
+              <a:rPr lang="en-US" sz="1400" dirty="0"/>
+              <a:t>Customer Records</a:t>
+            </a:r>
           </a:p>
         </p:txBody>
       </p:sp>
@@ -4207,12 +4293,11 @@
 </file>
 
 <file path=customXml/item1.xml><?xml version="1.0" encoding="utf-8"?>
-<?mso-contentType ?>
-<FormTemplates xmlns="http://schemas.microsoft.com/sharepoint/v3/contenttype/forms">
-  <Display>DocumentLibraryForm</Display>
-  <Edit>DocumentLibraryForm</Edit>
-  <New>DocumentLibraryForm</New>
-</FormTemplates>
+<p:properties xmlns:p="http://schemas.microsoft.com/office/2006/metadata/properties" xmlns:xsi="http://www.w3.org/2001/XMLSchema-instance" xmlns:pc="http://schemas.microsoft.com/office/infopath/2007/PartnerControls">
+  <documentManagement>
+    <_activity xmlns="819628f6-6e36-45a6-985d-41276b1fcfad" xsi:nil="true"/>
+  </documentManagement>
+</p:properties>
 </file>
 
 <file path=customXml/item2.xml><?xml version="1.0" encoding="utf-8"?>
@@ -4463,17 +4548,20 @@
 </file>
 
 <file path=customXml/item3.xml><?xml version="1.0" encoding="utf-8"?>
-<p:properties xmlns:p="http://schemas.microsoft.com/office/2006/metadata/properties" xmlns:xsi="http://www.w3.org/2001/XMLSchema-instance" xmlns:pc="http://schemas.microsoft.com/office/infopath/2007/PartnerControls">
-  <documentManagement>
-    <_activity xmlns="819628f6-6e36-45a6-985d-41276b1fcfad" xsi:nil="true"/>
-  </documentManagement>
-</p:properties>
+<?mso-contentType ?>
+<FormTemplates xmlns="http://schemas.microsoft.com/sharepoint/v3/contenttype/forms">
+  <Display>DocumentLibraryForm</Display>
+  <Edit>DocumentLibraryForm</Edit>
+  <New>DocumentLibraryForm</New>
+</FormTemplates>
 </file>
 
 <file path=customXml/itemProps1.xml><?xml version="1.0" encoding="utf-8"?>
-<ds:datastoreItem xmlns:ds="http://schemas.openxmlformats.org/officeDocument/2006/customXml" ds:itemID="{99FA970F-69EC-4F3F-91A5-17E1154BF453}">
+<ds:datastoreItem xmlns:ds="http://schemas.openxmlformats.org/officeDocument/2006/customXml" ds:itemID="{129E7507-8D97-4380-A599-9A8600FE4ECF}">
   <ds:schemaRefs>
-    <ds:schemaRef ds:uri="http://schemas.microsoft.com/sharepoint/v3/contenttype/forms"/>
+    <ds:schemaRef ds:uri="http://schemas.microsoft.com/office/2006/metadata/properties"/>
+    <ds:schemaRef ds:uri="http://schemas.microsoft.com/office/infopath/2007/PartnerControls"/>
+    <ds:schemaRef ds:uri="819628f6-6e36-45a6-985d-41276b1fcfad"/>
   </ds:schemaRefs>
 </ds:datastoreItem>
 </file>
@@ -4498,11 +4586,9 @@
 </file>
 
 <file path=customXml/itemProps3.xml><?xml version="1.0" encoding="utf-8"?>
-<ds:datastoreItem xmlns:ds="http://schemas.openxmlformats.org/officeDocument/2006/customXml" ds:itemID="{129E7507-8D97-4380-A599-9A8600FE4ECF}">
+<ds:datastoreItem xmlns:ds="http://schemas.openxmlformats.org/officeDocument/2006/customXml" ds:itemID="{99FA970F-69EC-4F3F-91A5-17E1154BF453}">
   <ds:schemaRefs>
-    <ds:schemaRef ds:uri="http://schemas.microsoft.com/office/2006/metadata/properties"/>
-    <ds:schemaRef ds:uri="http://schemas.microsoft.com/office/infopath/2007/PartnerControls"/>
-    <ds:schemaRef ds:uri="819628f6-6e36-45a6-985d-41276b1fcfad"/>
+    <ds:schemaRef ds:uri="http://schemas.microsoft.com/sharepoint/v3/contenttype/forms"/>
   </ds:schemaRefs>
 </ds:datastoreItem>
 </file>
</xml_diff>